<commit_message>
ajuste da explicabilidade dos calcululos
</commit_message>
<xml_diff>
--- a/fase2/video/Apresentacao_Fase2_Olist.pptx
+++ b/fase2/video/Apresentacao_Fase2_Olist.pptx
@@ -653,7 +653,7 @@
           <a:lstStyle/>
           <a:p>
             <a:r>
-              <a:t>[Jorge · 4:10–4:35] No cenário base: 670 atrasos evitados e cerca de 300 avaliações negativas a menos, 1.229 horas de triagem poupadas e 358 segundas compras adicionais. O ganho maior vem da combinação: menos atraso gera menos detrator e preserva a recompra.</a:t>
+              <a:t>[Jorge · 4:10–4:35] No cenário base: 672 atrasos evitados e 302 avaliações negativas a menos, 1.230 horas de triagem poupadas e 358 segundas compras adicionais. O ganho maior vem da combinação: menos atraso gera menos detrator e preserva a recompra.</a:t>
             </a:r>
           </a:p>
         </p:txBody>
@@ -4996,7 +4996,7 @@
                 </a:solidFill>
                 <a:latin typeface="Calibri"/>
               </a:rPr>
-              <a:t>670</a:t>
+              <a:t>672</a:t>
             </a:r>
           </a:p>
         </p:txBody>
@@ -5035,7 +5035,7 @@
                 </a:solidFill>
                 <a:latin typeface="Calibri"/>
               </a:rPr>
-              <a:t>atrasos evitados · ~300 notas 1–2 a menos (LogiPredict)</a:t>
+              <a:t>atrasos evitados · 302 notas 1–2 a menos (LogiPredict)</a:t>
             </a:r>
           </a:p>
         </p:txBody>
@@ -5074,7 +5074,7 @@
                 </a:solidFill>
                 <a:latin typeface="Calibri"/>
               </a:rPr>
-              <a:t>1.229 h</a:t>
+              <a:t>1.230 h</a:t>
             </a:r>
           </a:p>
         </p:txBody>
@@ -5204,8 +5204,8 @@
         </p:nvSpPr>
         <p:spPr>
           <a:xfrm>
-            <a:off x="640080" y="4023360"/>
-            <a:ext cx="10972800" cy="2011680"/>
+            <a:off x="640080" y="3246120"/>
+            <a:ext cx="3566160" cy="731520"/>
           </a:xfrm>
           <a:prstGeom prst="rect">
             <a:avLst/>
@@ -5224,7 +5224,124 @@
               </a:spcAft>
             </a:pPr>
             <a:r>
-              <a:rPr sz="1700" b="1">
+              <a:rPr sz="1200" b="0">
+                <a:solidFill>
+                  <a:srgbClr val="52514E"/>
+                </a:solidFill>
+                <a:latin typeface="Calibri"/>
+              </a:rPr>
+              <a:t>6.689 postagens atrasadas × 20,1 p.p. de atraso × 50% eliminado</a:t>
+            </a:r>
+          </a:p>
+        </p:txBody>
+      </p:sp>
+      <p:sp>
+        <p:nvSpPr>
+          <p:cNvPr id="14" name="TextBox 13"/>
+          <p:cNvSpPr txBox="1"/>
+          <p:nvPr/>
+        </p:nvSpPr>
+        <p:spPr>
+          <a:xfrm>
+            <a:off x="4480560" y="3246120"/>
+            <a:ext cx="3566160" cy="731520"/>
+          </a:xfrm>
+          <a:prstGeom prst="rect">
+            <a:avLst/>
+          </a:prstGeom>
+          <a:noFill/>
+        </p:spPr>
+        <p:txBody>
+          <a:bodyPr wrap="square" anchor="t">
+            <a:spAutoFit/>
+          </a:bodyPr>
+          <a:lstStyle/>
+          <a:p>
+            <a:pPr algn="l">
+              <a:spcAft>
+                <a:spcPts val="600"/>
+              </a:spcAft>
+            </a:pPr>
+            <a:r>
+              <a:rPr sz="1200" b="0">
+                <a:solidFill>
+                  <a:srgbClr val="52514E"/>
+                </a:solidFill>
+                <a:latin typeface="Calibri"/>
+              </a:rPr>
+              <a:t>11.711 avaliações 1–2 × 70% × 9 min poupados ÷ 60 × R$ 45/h</a:t>
+            </a:r>
+          </a:p>
+        </p:txBody>
+      </p:sp>
+      <p:sp>
+        <p:nvSpPr>
+          <p:cNvPr id="15" name="TextBox 14"/>
+          <p:cNvSpPr txBox="1"/>
+          <p:nvPr/>
+        </p:nvSpPr>
+        <p:spPr>
+          <a:xfrm>
+            <a:off x="8321040" y="3246120"/>
+            <a:ext cx="3566160" cy="731520"/>
+          </a:xfrm>
+          <a:prstGeom prst="rect">
+            <a:avLst/>
+          </a:prstGeom>
+          <a:noFill/>
+        </p:spPr>
+        <p:txBody>
+          <a:bodyPr wrap="square" anchor="t">
+            <a:spAutoFit/>
+          </a:bodyPr>
+          <a:lstStyle/>
+          <a:p>
+            <a:pPr algn="l">
+              <a:spcAft>
+                <a:spcPts val="600"/>
+              </a:spcAft>
+            </a:pPr>
+            <a:r>
+              <a:rPr sz="1200" b="0">
+                <a:solidFill>
+                  <a:srgbClr val="52514E"/>
+                </a:solidFill>
+                <a:latin typeface="Calibri"/>
+              </a:rPr>
+              <a:t>71.693 novos clientes × +0,5 p.p. de conversão × R$ 148,35</a:t>
+            </a:r>
+          </a:p>
+        </p:txBody>
+      </p:sp>
+      <p:sp>
+        <p:nvSpPr>
+          <p:cNvPr id="16" name="TextBox 15"/>
+          <p:cNvSpPr txBox="1"/>
+          <p:nvPr/>
+        </p:nvSpPr>
+        <p:spPr>
+          <a:xfrm>
+            <a:off x="640080" y="4206240"/>
+            <a:ext cx="10972800" cy="1828800"/>
+          </a:xfrm>
+          <a:prstGeom prst="rect">
+            <a:avLst/>
+          </a:prstGeom>
+          <a:noFill/>
+        </p:spPr>
+        <p:txBody>
+          <a:bodyPr wrap="square" anchor="t">
+            <a:spAutoFit/>
+          </a:bodyPr>
+          <a:lstStyle/>
+          <a:p>
+            <a:pPr algn="l">
+              <a:spcAft>
+                <a:spcPts val="600"/>
+              </a:spcAft>
+            </a:pPr>
+            <a:r>
+              <a:rPr sz="1600" b="1">
                 <a:solidFill>
                   <a:srgbClr val="0B0B0B"/>
                 </a:solidFill>
@@ -5233,7 +5350,7 @@
               <a:t>Metas do piloto (90 dias):</a:t>
             </a:r>
             <a:r>
-              <a:rPr sz="1700" b="0">
+              <a:rPr sz="1600" b="0">
                 <a:solidFill>
                   <a:srgbClr val="0B0B0B"/>
                 </a:solidFill>
@@ -5249,7 +5366,7 @@
               </a:spcAft>
             </a:pPr>
             <a:r>
-              <a:rPr sz="1700" b="1">
+              <a:rPr sz="1600" b="1">
                 <a:solidFill>
                   <a:srgbClr val="0B0B0B"/>
                 </a:solidFill>
@@ -5258,13 +5375,29 @@
               <a:t>Governança:</a:t>
             </a:r>
             <a:r>
-              <a:rPr sz="1700" b="0">
+              <a:rPr sz="1600" b="0">
                 <a:solidFill>
                   <a:srgbClr val="0B0B0B"/>
                 </a:solidFill>
                 <a:latin typeface="Calibri"/>
               </a:rPr>
               <a:t> agente executa o que é reversível; pessoas decidem compensação, transportadora e incentivo acima do teto.</a:t>
+            </a:r>
+          </a:p>
+          <a:p>
+            <a:pPr algn="l">
+              <a:spcAft>
+                <a:spcPts val="600"/>
+              </a:spcAft>
+            </a:pPr>
+            <a:r>
+              <a:rPr sz="1600" b="0">
+                <a:solidFill>
+                  <a:srgbClr val="0B0B0B"/>
+                </a:solidFill>
+                <a:latin typeface="Calibri"/>
+              </a:rPr>
+              <a:t>Memória de cálculo completa (entradas, premissas e contas): Seção 13.4 do relatório.</a:t>
             </a:r>
           </a:p>
         </p:txBody>

</xml_diff>